<commit_message>
docs(po): refresh the deck for the work that landed after it was rebuilt
Two claims on the deck went stale during the day it was rebuilt.

The risks slide still listed the seeded portal password as an open risk. It closed on
23 September (DEC-013): V19 replaced the committed digests and the real passwords now come from
the environment at startup. Replaced with what is actually left — one environment value covers
three hospital accounts, so three people share a credential, each row's own salt notwithstanding.
The speaker note says the closed half out loud rather than dropping it silently, because a risk
list that shrinks for a stated reason is the point of having one.

The status slide said 196 backend tests as 184. Same slide has said 138 and 184 on the way here;
each was true when written, and the note now says so instead of pretending the number was always
right.

Co-Authored-By: Claude Opus 5 (1M context) <noreply@anthropic.com>
</commit_message>
<xml_diff>
--- a/docs/po/presentations/LifeLinkKH-v2.pptx
+++ b/docs/po/presentations/LifeLinkKH-v2.pptx
@@ -852,32 +852,27 @@
           <a:lstStyle/>
           <a:p>
             <a:r>
-              <a:t>Test counts are re-run before every rebuild of this deck, not copied forward — the previous</a:t>
-            </a:r>
-          </a:p>
-          <a:p>
-            <a:r>
-              <a:t>version of this slide said 138 backend tests, which was true in August and is not now (184).</a:t>
-            </a:r>
-          </a:p>
-          <a:p>
-            <a:r>
-              <a:t>Both numbers come from a full unpiped run on 2026-09-23: `./mvnw test` with Docker up</a:t>
-            </a:r>
-          </a:p>
-          <a:p>
-            <a:r>
-              <a:t>(184 passed, 0 skipped — the Testcontainers integration tests silently skip when Docker is</a:t>
-            </a:r>
-          </a:p>
-          <a:p>
-            <a:r>
-              <a:t>down, so "0 skipped" is the number that matters, not "BUILD SUCCESS") and `flutter test`</a:t>
-            </a:r>
-          </a:p>
-          <a:p>
-            <a:r>
-              <a:t>(189 passed).</a:t>
+              <a:t>Test counts are re-run before every rebuild of this deck, not copied forward — this slide has</a:t>
+            </a:r>
+          </a:p>
+          <a:p>
+            <a:r>
+              <a:t>said 138 and then 184 on the way to today's 196, each one true when it was written. Both</a:t>
+            </a:r>
+          </a:p>
+          <a:p>
+            <a:r>
+              <a:t>numbers come from a full unpiped run on 2026-09-23: `./mvnw test` with Docker up (196 passed,</a:t>
+            </a:r>
+          </a:p>
+          <a:p>
+            <a:r>
+              <a:t>0 skipped — the Testcontainers integration tests silently skip when Docker is down, so "0</a:t>
+            </a:r>
+          </a:p>
+          <a:p>
+            <a:r>
+              <a:t>skipped" is the number that matters, not "BUILD SUCCESS") and `flutter test` (189 passed).</a:t>
             </a:r>
           </a:p>
           <a:p/>
@@ -1284,47 +1279,63 @@
           <a:p/>
           <a:p>
             <a:r>
-              <a:t>On the two security bullets, both dated the same way in docs/scope.md — fix before any real</a:t>
-            </a:r>
-          </a:p>
-          <a:p>
-            <a:r>
-              <a:t>donor's data is in this database, which is also FR-SECURITY-001's trigger. The seeded portal</a:t>
-            </a:r>
-          </a:p>
-          <a:p>
-            <a:r>
-              <a:t>password is in migrations V13-V16 and since V16 all four portal accounts share one value;</a:t>
-            </a:r>
-          </a:p>
-          <a:p>
-            <a:r>
-              <a:t>demo-runbook.md section 9 rotates it, and it must be rotated before this is demoed from a</a:t>
-            </a:r>
-          </a:p>
-          <a:p>
-            <a:r>
-              <a:t>projector. The public board publishes a named donor's blood type and district to anyone with</a:t>
-            </a:r>
-          </a:p>
-          <a:p>
-            <a:r>
-              <a:t>the link (DEC-009) — safe only because every donor row today is a team-created test account,</a:t>
-            </a:r>
-          </a:p>
-          <a:p>
-            <a:r>
-              <a:t>and there is no consent step because until that day there was nothing to consent to. Say both</a:t>
-            </a:r>
-          </a:p>
-          <a:p>
-            <a:r>
-              <a:t>out loud rather than waiting to be asked: each is a recorded choice with a recorded expiry,</a:t>
-            </a:r>
-          </a:p>
-          <a:p>
-            <a:r>
-              <a:t>which is a different thing from an oversight found at the defense.</a:t>
+              <a:t>On the two security bullets. The bigger one closed on 23 September and is worth saying out</a:t>
+            </a:r>
+          </a:p>
+          <a:p>
+            <a:r>
+              <a:t>loud as a closed item rather than leaving off the slide: until that day a password committed in</a:t>
+            </a:r>
+          </a:p>
+          <a:p>
+            <a:r>
+              <a:t>migrations V13-V16 opened all four portal accounts, including the ADMIN. V19 replaced those</a:t>
+            </a:r>
+          </a:p>
+          <a:p>
+            <a:r>
+              <a:t>digests with hashes of random values nobody holds, and the real passwords now come from the</a:t>
+            </a:r>
+          </a:p>
+          <a:p>
+            <a:r>
+              <a:t>environment at startup (DEC-013). What is left is narrower and is what the bullet says: one</a:t>
+            </a:r>
+          </a:p>
+          <a:p>
+            <a:r>
+              <a:t>environment value covers three hospital accounts, so three people share a credential. Each row</a:t>
+            </a:r>
+          </a:p>
+          <a:p>
+            <a:r>
+              <a:t>still carries its own salt, so cracking one does not open the others.</a:t>
+            </a:r>
+          </a:p>
+          <a:p/>
+          <a:p>
+            <a:r>
+              <a:t>The public board publishes a named donor's blood type and district to anyone with the link</a:t>
+            </a:r>
+          </a:p>
+          <a:p>
+            <a:r>
+              <a:t>(DEC-009) — safe only because every donor row today is a team-created test account, and there</a:t>
+            </a:r>
+          </a:p>
+          <a:p>
+            <a:r>
+              <a:t>is no consent step because until that day there was nothing to consent to. Say it rather than</a:t>
+            </a:r>
+          </a:p>
+          <a:p>
+            <a:r>
+              <a:t>waiting to be asked: a recorded choice with a recorded expiry is a different thing from an</a:t>
+            </a:r>
+          </a:p>
+          <a:p>
+            <a:r>
+              <a:t>oversight found at the defense.</a:t>
             </a:r>
           </a:p>
           <a:p/>
@@ -6500,7 +6511,7 @@
                 </a:solidFill>
                 <a:latin typeface="Helvetica Neue"/>
               </a:rPr>
-              <a:t>Backend: 184 tests green against real PostgreSQL via Testcontainers</a:t>
+              <a:t>Backend: 196 tests green against real PostgreSQL via Testcontainers</a:t>
             </a:r>
           </a:p>
           <a:p>
@@ -7191,7 +7202,7 @@
                 </a:solidFill>
                 <a:latin typeface="Helvetica Neue"/>
               </a:rPr>
-              <a:t>Seeded portal password sits in the repository — rotate before real data</a:t>
+              <a:t>Three hospital staff accounts share one password — one credential, three people</a:t>
             </a:r>
           </a:p>
           <a:p>

</xml_diff>

<commit_message>
docs(po): bring the deck up to today — two-way push and the 201/201 counts
Slide 10 gains the acceptance-push beat and loses "donor registers",
which the run-of-show pre-stages rather than shows live. Slide 12's test
counts are today's full runs (./mvnw verify 201, 0 skipped; flutter test
201), and FR-NOTIFY-003 leads the "since M7" bullet. run-of-show.md gets
the same beat at 1:15 and a warning that the requester must be on an FCM
device.

Co-Authored-By: Claude Opus 5.5 (1M context) <noreply@anthropic.com>
</commit_message>
<xml_diff>
--- a/docs/po/presentations/LifeLinkKH-v2.pptx
+++ b/docs/po/presentations/LifeLinkKH-v2.pptx
@@ -644,7 +644,12 @@
           </a:p>
           <a:p>
             <a:r>
-              <a:t>immediately before this one. The demo then runs post → push → accept → confirm → history, with</a:t>
+              <a:t>immediately before this one. The demo then runs post → push → accept → push back → confirm →</a:t>
+            </a:r>
+          </a:p>
+          <a:p>
+            <a:r>
+              <a:t>history, with</a:t>
             </a:r>
           </a:p>
           <a:p>
@@ -904,22 +909,27 @@
           </a:p>
           <a:p>
             <a:r>
-              <a:t>said 138 and then 184 on the way to today's 196, each one true when it was written. Both</a:t>
-            </a:r>
-          </a:p>
-          <a:p>
-            <a:r>
-              <a:t>numbers come from a full unpiped run on 2026-09-23: `./mvnw test` with Docker up (196 passed,</a:t>
-            </a:r>
-          </a:p>
-          <a:p>
-            <a:r>
-              <a:t>0 skipped — the Testcontainers integration tests silently skip when Docker is down, so "0</a:t>
-            </a:r>
-          </a:p>
-          <a:p>
-            <a:r>
-              <a:t>skipped" is the number that matters, not "BUILD SUCCESS") and `flutter test` (189 passed).</a:t>
+              <a:t>said 138, 184 and 196 on the way to today's 201, each one true when it was written. Both</a:t>
+            </a:r>
+          </a:p>
+          <a:p>
+            <a:r>
+              <a:t>numbers come from full runs on 2026-09-25: `./mvnw verify` with Docker up (201 passed, 0</a:t>
+            </a:r>
+          </a:p>
+          <a:p>
+            <a:r>
+              <a:t>skipped — the Testcontainers integration tests silently skip when Docker is down, so "0</a:t>
+            </a:r>
+          </a:p>
+          <a:p>
+            <a:r>
+              <a:t>skipped" is the number that matters, not "BUILD SUCCESS") and `flutter test` (201 passed).</a:t>
+            </a:r>
+          </a:p>
+          <a:p>
+            <a:r>
+              <a:t>That the two are equal is a coincidence, not a typo.</a:t>
             </a:r>
           </a:p>
           <a:p/>
@@ -946,7 +956,17 @@
           <a:p/>
           <a:p>
             <a:r>
-              <a:t>The fourth bullet is work that grew AFTER the graded milestones, in September: the public</a:t>
+              <a:t>The fourth bullet is work that grew AFTER the graded milestones, in September. Newest first:</a:t>
+            </a:r>
+          </a:p>
+          <a:p>
+            <a:r>
+              <a:t>two-way push (FR-NOTIFY-003, 2026-09-25) — the family who posted is now told when a donor</a:t>
+            </a:r>
+          </a:p>
+          <a:p>
+            <a:r>
+              <a:t>accepts; until then push went to donors only and the requester waited in silence. Then the public</a:t>
             </a:r>
           </a:p>
           <a:p>
@@ -5804,7 +5824,7 @@
                 </a:solidFill>
                 <a:latin typeface="Helvetica Neue"/>
               </a:rPr>
-              <a:t>Donor registers — Google Sign-in, blood type, district, no password</a:t>
+              <a:t>Requester creates an urgent request — blood type, urgency, hospital</a:t>
             </a:r>
           </a:p>
           <a:p>
@@ -5829,7 +5849,7 @@
                 </a:solidFill>
                 <a:latin typeface="Helvetica Neue"/>
               </a:rPr>
-              <a:t>Requester creates an urgent request — blood type, urgency, hospital</a:t>
+              <a:t>Push notification fires — instant, targeted, not a Facebook scroll</a:t>
             </a:r>
           </a:p>
           <a:p>
@@ -5854,7 +5874,7 @@
                 </a:solidFill>
                 <a:latin typeface="Helvetica Neue"/>
               </a:rPr>
-              <a:t>Push notification fires — instant, targeted, not a Facebook scroll</a:t>
+              <a:t>Donor accepts — and the family's phone is told a donor is coming</a:t>
             </a:r>
           </a:p>
           <a:p>
@@ -5879,7 +5899,7 @@
                 </a:solidFill>
                 <a:latin typeface="Helvetica Neue"/>
               </a:rPr>
-              <a:t>Donor accepts; hospital confirms on the portal — cooldown starts</a:t>
+              <a:t>Hospital confirms on the portal — the 56-day cooldown starts</a:t>
             </a:r>
           </a:p>
           <a:p>
@@ -6558,7 +6578,7 @@
                 </a:solidFill>
                 <a:latin typeface="Helvetica Neue"/>
               </a:rPr>
-              <a:t>Backend: 196 tests green against real PostgreSQL via Testcontainers</a:t>
+              <a:t>Backend: 201 tests green against real PostgreSQL via Testcontainers</a:t>
             </a:r>
           </a:p>
           <a:p>
@@ -6583,7 +6603,7 @@
                 </a:solidFill>
                 <a:latin typeface="Helvetica Neue"/>
               </a:rPr>
-              <a:t>Mobile: 189 tests green — iOS and Android both build today</a:t>
+              <a:t>Mobile: 201 tests green — iOS and Android both build today</a:t>
             </a:r>
           </a:p>
           <a:p>
@@ -6608,7 +6628,7 @@
                 </a:solidFill>
                 <a:latin typeface="Helvetica Neue"/>
               </a:rPr>
-              <a:t>Since M7: public request board, portal staff accounts, mobile language switch</a:t>
+              <a:t>Since M7: two-way push, public board, portal staff accounts, language switch</a:t>
             </a:r>
           </a:p>
           <a:p>

</xml_diff>

<commit_message>
docs: recapture the app and portal screenshots from today's build
The README and the deck's two screenshot slides showed the 22 September
build. Since then Home became one screen for everyone with the donation
guide link, History says when you can give again, and the portal shows
an accepted donor with the confirm button — which the old staff shot,
all rows collapsed, never did.

Mobile: Home, Profile, History from the API 36 emulator at 1080x2400 in
Khmer, status bar in demo mode. Portal: public board (km, en) and the
calmette staff view with the critical O+ row open, via headless Chrome
at 1440x900 x2, light mode to match the set. Seeded demo data. The intro
is unchanged since the last capture and keeps its image.

Deck rebuilt; the staff caption now says what the image shows.

Co-Authored-By: Claude Opus 5.5 (1M context) <noreply@anthropic.com>
</commit_message>
<xml_diff>
--- a/docs/po/presentations/LifeLinkKH-v2.pptx
+++ b/docs/po/presentations/LifeLinkKH-v2.pptx
@@ -2489,7 +2489,17 @@
           <a:p/>
           <a:p>
             <a:r>
-              <a:t>Staff accounts (right) replaced a JWT pasted into a .env file by hand (DEC-010). Nobody</a:t>
+              <a:t>The right-hand shot is the moment the demo ends on: a donor who accepted, and the confirm</a:t>
+            </a:r>
+          </a:p>
+          <a:p>
+            <a:r>
+              <a:t>button whose click starts their 56-day cooldown. Staff accounts replaced a JWT pasted into a</a:t>
+            </a:r>
+          </a:p>
+          <a:p>
+            <a:r>
+              <a:t>.env file by hand (DEC-010). Nobody</a:t>
             </a:r>
           </a:p>
           <a:p>
@@ -10129,8 +10139,8 @@
         </p:blipFill>
         <p:spPr>
           <a:xfrm>
-            <a:off x="800124" y="2395728"/>
-            <a:ext cx="5781702" cy="2834640"/>
+            <a:off x="1423263" y="2395728"/>
+            <a:ext cx="4535424" cy="2834640"/>
           </a:xfrm>
           <a:prstGeom prst="rect">
             <a:avLst/>
@@ -10153,7 +10163,7 @@
         </p:blipFill>
         <p:spPr>
           <a:xfrm>
-            <a:off x="6856146" y="2395728"/>
+            <a:off x="6233007" y="2395728"/>
             <a:ext cx="4535424" cy="2834640"/>
           </a:xfrm>
           <a:prstGeom prst="rect">
@@ -10169,42 +10179,7 @@
         </p:nvSpPr>
         <p:spPr>
           <a:xfrm>
-            <a:off x="800124" y="5303520"/>
-            <a:ext cx="5781702" cy="457200"/>
-          </a:xfrm>
-          <a:prstGeom prst="rect">
-            <a:avLst/>
-          </a:prstGeom>
-          <a:noFill/>
-        </p:spPr>
-        <p:txBody>
-          <a:bodyPr wrap="square">
-            <a:spAutoFit/>
-          </a:bodyPr>
-          <a:lstStyle/>
-          <a:p>
-            <a:pPr algn="ctr"/>
-            <a:r>
-              <a:rPr sz="1300" b="0">
-                <a:solidFill>
-                  <a:srgbClr val="5A5A6E"/>
-                </a:solidFill>
-                <a:latin typeface="Helvetica Neue"/>
-              </a:rPr>
-              <a:t>Public board — open requests, no account needed</a:t>
-            </a:r>
-          </a:p>
-        </p:txBody>
-      </p:sp>
-      <p:sp>
-        <p:nvSpPr>
-          <p:cNvPr id="7" name="TextBox 6"/>
-          <p:cNvSpPr txBox="1"/>
-          <p:nvPr/>
-        </p:nvSpPr>
-        <p:spPr>
-          <a:xfrm>
-            <a:off x="6856146" y="5303520"/>
+            <a:off x="1423263" y="5303520"/>
             <a:ext cx="4535424" cy="457200"/>
           </a:xfrm>
           <a:prstGeom prst="rect">
@@ -10226,7 +10201,42 @@
                 </a:solidFill>
                 <a:latin typeface="Helvetica Neue"/>
               </a:rPr>
-              <a:t>The same board, signed in as hospital staff</a:t>
+              <a:t>Public board — open requests, no account needed</a:t>
+            </a:r>
+          </a:p>
+        </p:txBody>
+      </p:sp>
+      <p:sp>
+        <p:nvSpPr>
+          <p:cNvPr id="7" name="TextBox 6"/>
+          <p:cNvSpPr txBox="1"/>
+          <p:nvPr/>
+        </p:nvSpPr>
+        <p:spPr>
+          <a:xfrm>
+            <a:off x="6233007" y="5303520"/>
+            <a:ext cx="4535424" cy="457200"/>
+          </a:xfrm>
+          <a:prstGeom prst="rect">
+            <a:avLst/>
+          </a:prstGeom>
+          <a:noFill/>
+        </p:spPr>
+        <p:txBody>
+          <a:bodyPr wrap="square">
+            <a:spAutoFit/>
+          </a:bodyPr>
+          <a:lstStyle/>
+          <a:p>
+            <a:pPr algn="ctr"/>
+            <a:r>
+              <a:rPr sz="1300" b="0">
+                <a:solidFill>
+                  <a:srgbClr val="5A5A6E"/>
+                </a:solidFill>
+                <a:latin typeface="Helvetica Neue"/>
+              </a:rPr>
+              <a:t>Hospital staff — an accepted donor, one click to confirm</a:t>
             </a:r>
           </a:p>
         </p:txBody>

</xml_diff>